<commit_message>
docs: repair the charts PowerPoint rejected
PowerPoint asked to repair the deck and would not open the poster.
Every chart gave one run property two latin faces, where the schema
allows one, and negative axis ids, where it asks for unsigned ones.
Each chart now keeps one latin, ea and cs face in schema order and
positive ids. Both files pass the ISO/IEC 29500 schemas part by part
and the Open XML SDK validator with no errors.
</commit_message>
<xml_diff>
--- a/presentations/20261030_進捗報告.pptx
+++ b/presentations/20261030_進捗報告.pptx
@@ -897,11 +897,11 @@
         </c:ser>
         <c:gapWidth val="50"/>
         <c:overlap val="-5"/>
-        <c:axId val="-2068027336"/>
-        <c:axId val="-2113994440"/>
+        <c:axId val="2068027336"/>
+        <c:axId val="2113994440"/>
       </c:barChart>
       <c:catAx>
-        <c:axId val="-2068027336"/>
+        <c:axId val="2068027336"/>
         <c:scaling>
           <c:orientation val="minMax"/>
         </c:scaling>
@@ -926,7 +926,7 @@
             </a:pPr>
           </a:p>
         </c:txPr>
-        <c:crossAx val="-2113994440"/>
+        <c:crossAx val="2113994440"/>
         <c:crosses val="autoZero"/>
         <c:auto val="1"/>
         <c:lblAlgn val="ctr"/>
@@ -934,7 +934,7 @@
         <c:noMultiLvlLbl val="0"/>
       </c:catAx>
       <c:valAx>
-        <c:axId val="-2113994440"/>
+        <c:axId val="2113994440"/>
         <c:scaling>
           <c:max val="50.0"/>
           <c:min val="0.0"/>
@@ -971,7 +971,7 @@
             </a:pPr>
           </a:p>
         </c:txPr>
-        <c:crossAx val="-2068027336"/>
+        <c:crossAx val="2068027336"/>
         <c:crosses val="autoZero"/>
         <c:majorUnit val="10.0"/>
       </c:valAx>
@@ -999,7 +999,6 @@
     <a:p>
       <a:pPr>
         <a:defRPr sz="1400">
-          <a:latin typeface="游明朝"/>
           <a:latin typeface="游明朝"/>
           <a:ea typeface="游明朝"/>
         </a:defRPr>

</xml_diff>